<commit_message>
Pitch deck: fix text overflows + bump price to 3000€
Visual fixes after QA pass:
- Slide 2 (le constat): big stats centered vertically, "−40%" no longer
  wraps to a second line. Font 72pt → 60pt with center valign.
- Slide 7 (ROI): drop the space-and-slash separator that caused wrapping
  ("+450 €" was breaking after the digits). Now reads "+450€ / par mois",
  "−2h / par semaine", "+3 / séances/mois" — all stay on one line.
- Slide 8 (pricing): price bumped from 2 500€ to 3 000€ (Evan's call),
  font reduced 100pt → 80pt with middle valign so the figure stays on
  one line inside the white card. Subline moved down accordingly.

🤖 Generated with Claude Code
</commit_message>
<xml_diff>
--- a/pitch-deck.pptx
+++ b/pitch-deck.pptx
@@ -3092,24 +3092,24 @@
         </p:nvSpPr>
         <p:spPr>
           <a:xfrm>
-            <a:off x="731520" y="2743200"/>
-            <a:ext cx="3017520" cy="1463040"/>
-          </a:xfrm>
-          <a:prstGeom prst="rect">
-            <a:avLst/>
-          </a:prstGeom>
-          <a:noFill/>
-          <a:ln/>
-        </p:spPr>
-        <p:txBody>
-          <a:bodyPr wrap="square" rtlCol="0" anchor="t"/>
-          <a:lstStyle/>
-          <a:p>
-            <a:pPr indent="0" marL="0">
-              <a:buNone/>
-            </a:pPr>
-            <a:r>
-              <a:rPr lang="en-US" sz="7200" b="1" dirty="0">
+            <a:off x="731520" y="2834640"/>
+            <a:ext cx="3017520" cy="1280160"/>
+          </a:xfrm>
+          <a:prstGeom prst="rect">
+            <a:avLst/>
+          </a:prstGeom>
+          <a:noFill/>
+          <a:ln/>
+        </p:spPr>
+        <p:txBody>
+          <a:bodyPr wrap="square" rtlCol="0" anchor="ctr"/>
+          <a:lstStyle/>
+          <a:p>
+            <a:pPr algn="ctr" indent="0" marL="0">
+              <a:buNone/>
+            </a:pPr>
+            <a:r>
+              <a:rPr lang="en-US" sz="6000" b="1" dirty="0">
                 <a:solidFill>
                   <a:srgbClr val="1A1A1A"/>
                 </a:solidFill>
@@ -3117,9 +3117,9 @@
                 <a:ea typeface="Georgia" pitchFamily="34" charset="-122"/>
                 <a:cs typeface="Georgia" pitchFamily="34" charset="-120"/>
               </a:rPr>
-              <a:t>70%</a:t>
-            </a:r>
-            <a:endParaRPr lang="en-US" sz="7200" dirty="0"/>
+              <a:t>70 %</a:t>
+            </a:r>
+            <a:endParaRPr lang="en-US" sz="6000" dirty="0"/>
           </a:p>
         </p:txBody>
       </p:sp>
@@ -3131,8 +3131,8 @@
         </p:nvSpPr>
         <p:spPr>
           <a:xfrm>
-            <a:off x="731520" y="4206240"/>
-            <a:ext cx="3017520" cy="1097280"/>
+            <a:off x="822960" y="4297680"/>
+            <a:ext cx="2834640" cy="1005840"/>
           </a:xfrm>
           <a:prstGeom prst="rect">
             <a:avLst/>
@@ -3144,11 +3144,11 @@
           <a:bodyPr wrap="square" rtlCol="0" anchor="t"/>
           <a:lstStyle/>
           <a:p>
-            <a:pPr indent="0" marL="0">
-              <a:buNone/>
-            </a:pPr>
-            <a:r>
-              <a:rPr lang="en-US" sz="1400" dirty="0">
+            <a:pPr algn="ctr" indent="0" marL="0">
+              <a:buNone/>
+            </a:pPr>
+            <a:r>
+              <a:rPr lang="en-US" sz="1300" dirty="0">
                 <a:solidFill>
                   <a:srgbClr val="6B6B6B"/>
                 </a:solidFill>
@@ -3158,7 +3158,7 @@
               </a:rPr>
               <a:t>des sites de photographes pro sont des WordPress avec galerie statique — aucune vraie automatisation.</a:t>
             </a:r>
-            <a:endParaRPr lang="en-US" sz="1400" dirty="0"/>
+            <a:endParaRPr lang="en-US" sz="1300" dirty="0"/>
           </a:p>
         </p:txBody>
       </p:sp>
@@ -3220,24 +3220,24 @@
         </p:nvSpPr>
         <p:spPr>
           <a:xfrm>
-            <a:off x="4572000" y="2743200"/>
-            <a:ext cx="3017520" cy="1463040"/>
-          </a:xfrm>
-          <a:prstGeom prst="rect">
-            <a:avLst/>
-          </a:prstGeom>
-          <a:noFill/>
-          <a:ln/>
-        </p:spPr>
-        <p:txBody>
-          <a:bodyPr wrap="square" rtlCol="0" anchor="t"/>
-          <a:lstStyle/>
-          <a:p>
-            <a:pPr indent="0" marL="0">
-              <a:buNone/>
-            </a:pPr>
-            <a:r>
-              <a:rPr lang="en-US" sz="7200" b="1" dirty="0">
+            <a:off x="4572000" y="2834640"/>
+            <a:ext cx="3017520" cy="1280160"/>
+          </a:xfrm>
+          <a:prstGeom prst="rect">
+            <a:avLst/>
+          </a:prstGeom>
+          <a:noFill/>
+          <a:ln/>
+        </p:spPr>
+        <p:txBody>
+          <a:bodyPr wrap="square" rtlCol="0" anchor="ctr"/>
+          <a:lstStyle/>
+          <a:p>
+            <a:pPr algn="ctr" indent="0" marL="0">
+              <a:buNone/>
+            </a:pPr>
+            <a:r>
+              <a:rPr lang="en-US" sz="6000" b="1" dirty="0">
                 <a:solidFill>
                   <a:srgbClr val="1A1A1A"/>
                 </a:solidFill>
@@ -3245,9 +3245,9 @@
                 <a:ea typeface="Georgia" pitchFamily="34" charset="-122"/>
                 <a:cs typeface="Georgia" pitchFamily="34" charset="-120"/>
               </a:rPr>
-              <a:t>3h+</a:t>
-            </a:r>
-            <a:endParaRPr lang="en-US" sz="7200" dirty="0"/>
+              <a:t>3 h+</a:t>
+            </a:r>
+            <a:endParaRPr lang="en-US" sz="6000" dirty="0"/>
           </a:p>
         </p:txBody>
       </p:sp>
@@ -3259,8 +3259,8 @@
         </p:nvSpPr>
         <p:spPr>
           <a:xfrm>
-            <a:off x="4572000" y="4206240"/>
-            <a:ext cx="3017520" cy="1097280"/>
+            <a:off x="4663440" y="4297680"/>
+            <a:ext cx="2834640" cy="1005840"/>
           </a:xfrm>
           <a:prstGeom prst="rect">
             <a:avLst/>
@@ -3272,11 +3272,11 @@
           <a:bodyPr wrap="square" rtlCol="0" anchor="t"/>
           <a:lstStyle/>
           <a:p>
-            <a:pPr indent="0" marL="0">
-              <a:buNone/>
-            </a:pPr>
-            <a:r>
-              <a:rPr lang="en-US" sz="1400" dirty="0">
+            <a:pPr algn="ctr" indent="0" marL="0">
+              <a:buNone/>
+            </a:pPr>
+            <a:r>
+              <a:rPr lang="en-US" sz="1300" dirty="0">
                 <a:solidFill>
                   <a:srgbClr val="6B6B6B"/>
                 </a:solidFill>
@@ -3286,7 +3286,7 @@
               </a:rPr>
               <a:t>passées chaque semaine par le photographe à faire de la facturation, du suivi et de la livraison manuelle.</a:t>
             </a:r>
-            <a:endParaRPr lang="en-US" sz="1400" dirty="0"/>
+            <a:endParaRPr lang="en-US" sz="1300" dirty="0"/>
           </a:p>
         </p:txBody>
       </p:sp>
@@ -3348,24 +3348,24 @@
         </p:nvSpPr>
         <p:spPr>
           <a:xfrm>
-            <a:off x="8412480" y="2743200"/>
-            <a:ext cx="3017520" cy="1463040"/>
-          </a:xfrm>
-          <a:prstGeom prst="rect">
-            <a:avLst/>
-          </a:prstGeom>
-          <a:noFill/>
-          <a:ln/>
-        </p:spPr>
-        <p:txBody>
-          <a:bodyPr wrap="square" rtlCol="0" anchor="t"/>
-          <a:lstStyle/>
-          <a:p>
-            <a:pPr indent="0" marL="0">
-              <a:buNone/>
-            </a:pPr>
-            <a:r>
-              <a:rPr lang="en-US" sz="7200" b="1" dirty="0">
+            <a:off x="8412480" y="2834640"/>
+            <a:ext cx="3017520" cy="1280160"/>
+          </a:xfrm>
+          <a:prstGeom prst="rect">
+            <a:avLst/>
+          </a:prstGeom>
+          <a:noFill/>
+          <a:ln/>
+        </p:spPr>
+        <p:txBody>
+          <a:bodyPr wrap="square" rtlCol="0" anchor="ctr"/>
+          <a:lstStyle/>
+          <a:p>
+            <a:pPr algn="ctr" indent="0" marL="0">
+              <a:buNone/>
+            </a:pPr>
+            <a:r>
+              <a:rPr lang="en-US" sz="6000" b="1" dirty="0">
                 <a:solidFill>
                   <a:srgbClr val="1A1A1A"/>
                 </a:solidFill>
@@ -3373,9 +3373,9 @@
                 <a:ea typeface="Georgia" pitchFamily="34" charset="-122"/>
                 <a:cs typeface="Georgia" pitchFamily="34" charset="-120"/>
               </a:rPr>
-              <a:t>—40%</a:t>
-            </a:r>
-            <a:endParaRPr lang="en-US" sz="7200" dirty="0"/>
+              <a:t>−40 %</a:t>
+            </a:r>
+            <a:endParaRPr lang="en-US" sz="6000" dirty="0"/>
           </a:p>
         </p:txBody>
       </p:sp>
@@ -3387,8 +3387,8 @@
         </p:nvSpPr>
         <p:spPr>
           <a:xfrm>
-            <a:off x="8412480" y="4206240"/>
-            <a:ext cx="3017520" cy="1097280"/>
+            <a:off x="8503920" y="4297680"/>
+            <a:ext cx="2834640" cy="1005840"/>
           </a:xfrm>
           <a:prstGeom prst="rect">
             <a:avLst/>
@@ -3400,11 +3400,11 @@
           <a:bodyPr wrap="square" rtlCol="0" anchor="t"/>
           <a:lstStyle/>
           <a:p>
-            <a:pPr indent="0" marL="0">
-              <a:buNone/>
-            </a:pPr>
-            <a:r>
-              <a:rPr lang="en-US" sz="1400" dirty="0">
+            <a:pPr algn="ctr" indent="0" marL="0">
+              <a:buNone/>
+            </a:pPr>
+            <a:r>
+              <a:rPr lang="en-US" sz="1300" dirty="0">
                 <a:solidFill>
                   <a:srgbClr val="6B6B6B"/>
                 </a:solidFill>
@@ -3414,7 +3414,7 @@
               </a:rPr>
               <a:t>de chiffre d'affaires potentiel perdu : pas de boutique tirages, pas de réservation directe en ligne.</a:t>
             </a:r>
-            <a:endParaRPr lang="en-US" sz="1400" dirty="0"/>
+            <a:endParaRPr lang="en-US" sz="1300" dirty="0"/>
           </a:p>
         </p:txBody>
       </p:sp>
@@ -7733,7 +7733,7 @@
         <p:spPr>
           <a:xfrm>
             <a:off x="594360" y="2743200"/>
-            <a:ext cx="3108960" cy="1280160"/>
+            <a:ext cx="3108960" cy="1371600"/>
           </a:xfrm>
           <a:prstGeom prst="rect">
             <a:avLst/>
@@ -7749,7 +7749,7 @@
               <a:buNone/>
             </a:pPr>
             <a:r>
-              <a:rPr lang="en-US" sz="5600" b="1" dirty="0">
+              <a:rPr lang="en-US" sz="6400" b="1" dirty="0">
                 <a:solidFill>
                   <a:srgbClr val="1A1A1A"/>
                 </a:solidFill>
@@ -7757,9 +7757,9 @@
                 <a:ea typeface="Georgia" pitchFamily="34" charset="-122"/>
                 <a:cs typeface="Georgia" pitchFamily="34" charset="-120"/>
               </a:rPr>
-              <a:t>+3 séances</a:t>
-            </a:r>
-            <a:endParaRPr lang="en-US" sz="5600" dirty="0"/>
+              <a:t>+3</a:t>
+            </a:r>
+            <a:endParaRPr lang="en-US" sz="6400" dirty="0"/>
           </a:p>
         </p:txBody>
       </p:sp>
@@ -7771,7 +7771,7 @@
         </p:nvSpPr>
         <p:spPr>
           <a:xfrm>
-            <a:off x="594360" y="4023360"/>
+            <a:off x="594360" y="4160520"/>
             <a:ext cx="3108960" cy="365760"/>
           </a:xfrm>
           <a:prstGeom prst="rect">
@@ -7788,7 +7788,7 @@
               <a:buNone/>
             </a:pPr>
             <a:r>
-              <a:rPr lang="en-US" sz="1600" i="1" dirty="0">
+              <a:rPr lang="en-US" sz="1400" i="1" dirty="0">
                 <a:solidFill>
                   <a:srgbClr val="6B6B6B"/>
                 </a:solidFill>
@@ -7796,9 +7796,9 @@
                 <a:ea typeface="Calibri" pitchFamily="34" charset="-122"/>
                 <a:cs typeface="Calibri" pitchFamily="34" charset="-120"/>
               </a:rPr>
-              <a:t>/ mois</a:t>
-            </a:r>
-            <a:endParaRPr lang="en-US" sz="1600" dirty="0"/>
+              <a:t>séances / mois</a:t>
+            </a:r>
+            <a:endParaRPr lang="en-US" sz="1400" dirty="0"/>
           </a:p>
         </p:txBody>
       </p:sp>
@@ -7875,7 +7875,7 @@
         <p:spPr>
           <a:xfrm>
             <a:off x="4526280" y="2743200"/>
-            <a:ext cx="3108960" cy="1280160"/>
+            <a:ext cx="3108960" cy="1371600"/>
           </a:xfrm>
           <a:prstGeom prst="rect">
             <a:avLst/>
@@ -7891,7 +7891,7 @@
               <a:buNone/>
             </a:pPr>
             <a:r>
-              <a:rPr lang="en-US" sz="5600" b="1" dirty="0">
+              <a:rPr lang="en-US" sz="6400" b="1" dirty="0">
                 <a:solidFill>
                   <a:srgbClr val="C8A97E"/>
                 </a:solidFill>
@@ -7899,9 +7899,9 @@
                 <a:ea typeface="Georgia" pitchFamily="34" charset="-122"/>
                 <a:cs typeface="Georgia" pitchFamily="34" charset="-120"/>
               </a:rPr>
-              <a:t>+450 €</a:t>
-            </a:r>
-            <a:endParaRPr lang="en-US" sz="5600" dirty="0"/>
+              <a:t>+450€</a:t>
+            </a:r>
+            <a:endParaRPr lang="en-US" sz="6400" dirty="0"/>
           </a:p>
         </p:txBody>
       </p:sp>
@@ -7913,7 +7913,7 @@
         </p:nvSpPr>
         <p:spPr>
           <a:xfrm>
-            <a:off x="4526280" y="4023360"/>
+            <a:off x="4526280" y="4160520"/>
             <a:ext cx="3108960" cy="365760"/>
           </a:xfrm>
           <a:prstGeom prst="rect">
@@ -7930,7 +7930,7 @@
               <a:buNone/>
             </a:pPr>
             <a:r>
-              <a:rPr lang="en-US" sz="1600" i="1" dirty="0">
+              <a:rPr lang="en-US" sz="1400" i="1" dirty="0">
                 <a:solidFill>
                   <a:srgbClr val="FFFFFF"/>
                 </a:solidFill>
@@ -7938,9 +7938,9 @@
                 <a:ea typeface="Calibri" pitchFamily="34" charset="-122"/>
                 <a:cs typeface="Calibri" pitchFamily="34" charset="-120"/>
               </a:rPr>
-              <a:t>/ mois</a:t>
-            </a:r>
-            <a:endParaRPr lang="en-US" sz="1600" dirty="0"/>
+              <a:t>par mois</a:t>
+            </a:r>
+            <a:endParaRPr lang="en-US" sz="1400" dirty="0"/>
           </a:p>
         </p:txBody>
       </p:sp>
@@ -7977,7 +7977,7 @@
                 <a:ea typeface="Calibri" pitchFamily="34" charset="-122"/>
                 <a:cs typeface="Calibri" pitchFamily="34" charset="-120"/>
               </a:rPr>
-              <a:t>estimés via la boutique tirages (5 tirages vendus à 90 € de marge moyenne).</a:t>
+              <a:t>estimés via la boutique tirages (5 tirages vendus à 90€ de marge moyenne).</a:t>
             </a:r>
             <a:endParaRPr lang="en-US" sz="1200" dirty="0"/>
           </a:p>
@@ -8017,7 +8017,7 @@
         <p:spPr>
           <a:xfrm>
             <a:off x="8458200" y="2743200"/>
-            <a:ext cx="3108960" cy="1280160"/>
+            <a:ext cx="3108960" cy="1371600"/>
           </a:xfrm>
           <a:prstGeom prst="rect">
             <a:avLst/>
@@ -8033,7 +8033,7 @@
               <a:buNone/>
             </a:pPr>
             <a:r>
-              <a:rPr lang="en-US" sz="5600" b="1" dirty="0">
+              <a:rPr lang="en-US" sz="6400" b="1" dirty="0">
                 <a:solidFill>
                   <a:srgbClr val="1A1A1A"/>
                 </a:solidFill>
@@ -8041,9 +8041,9 @@
                 <a:ea typeface="Georgia" pitchFamily="34" charset="-122"/>
                 <a:cs typeface="Georgia" pitchFamily="34" charset="-120"/>
               </a:rPr>
-              <a:t>—2h</a:t>
-            </a:r>
-            <a:endParaRPr lang="en-US" sz="5600" dirty="0"/>
+              <a:t>−2h</a:t>
+            </a:r>
+            <a:endParaRPr lang="en-US" sz="6400" dirty="0"/>
           </a:p>
         </p:txBody>
       </p:sp>
@@ -8055,7 +8055,7 @@
         </p:nvSpPr>
         <p:spPr>
           <a:xfrm>
-            <a:off x="8458200" y="4023360"/>
+            <a:off x="8458200" y="4160520"/>
             <a:ext cx="3108960" cy="365760"/>
           </a:xfrm>
           <a:prstGeom prst="rect">
@@ -8072,7 +8072,7 @@
               <a:buNone/>
             </a:pPr>
             <a:r>
-              <a:rPr lang="en-US" sz="1600" i="1" dirty="0">
+              <a:rPr lang="en-US" sz="1400" i="1" dirty="0">
                 <a:solidFill>
                   <a:srgbClr val="6B6B6B"/>
                 </a:solidFill>
@@ -8080,9 +8080,9 @@
                 <a:ea typeface="Calibri" pitchFamily="34" charset="-122"/>
                 <a:cs typeface="Calibri" pitchFamily="34" charset="-120"/>
               </a:rPr>
-              <a:t>/ semaine</a:t>
-            </a:r>
-            <a:endParaRPr lang="en-US" sz="1600" dirty="0"/>
+              <a:t>par semaine</a:t>
+            </a:r>
+            <a:endParaRPr lang="en-US" sz="1400" dirty="0"/>
           </a:p>
         </p:txBody>
       </p:sp>
@@ -8424,24 +8424,24 @@
         </p:nvSpPr>
         <p:spPr>
           <a:xfrm>
-            <a:off x="2011680" y="2834640"/>
-            <a:ext cx="5029200" cy="1280160"/>
-          </a:xfrm>
-          <a:prstGeom prst="rect">
-            <a:avLst/>
-          </a:prstGeom>
-          <a:noFill/>
-          <a:ln/>
-        </p:spPr>
-        <p:txBody>
-          <a:bodyPr wrap="square" rtlCol="0" anchor="ctr"/>
-          <a:lstStyle/>
-          <a:p>
-            <a:pPr indent="0" marL="0">
-              <a:buNone/>
-            </a:pPr>
-            <a:r>
-              <a:rPr lang="en-US" sz="10000" b="1" dirty="0">
+            <a:off x="2011680" y="2926080"/>
+            <a:ext cx="5029200" cy="1463040"/>
+          </a:xfrm>
+          <a:prstGeom prst="rect">
+            <a:avLst/>
+          </a:prstGeom>
+          <a:noFill/>
+          <a:ln/>
+        </p:spPr>
+        <p:txBody>
+          <a:bodyPr wrap="square" rtlCol="0" anchor="ctr"/>
+          <a:lstStyle/>
+          <a:p>
+            <a:pPr indent="0" marL="0">
+              <a:buNone/>
+            </a:pPr>
+            <a:r>
+              <a:rPr lang="en-US" sz="8000" b="1" dirty="0">
                 <a:solidFill>
                   <a:srgbClr val="1A1A1A"/>
                 </a:solidFill>
@@ -8449,9 +8449,9 @@
                 <a:ea typeface="Georgia" pitchFamily="34" charset="-122"/>
                 <a:cs typeface="Georgia" pitchFamily="34" charset="-120"/>
               </a:rPr>
-              <a:t>2 500 €</a:t>
-            </a:r>
-            <a:endParaRPr lang="en-US" sz="10000" dirty="0"/>
+              <a:t>3 000 €</a:t>
+            </a:r>
+            <a:endParaRPr lang="en-US" sz="8000" dirty="0"/>
           </a:p>
         </p:txBody>
       </p:sp>
@@ -8463,7 +8463,7 @@
         </p:nvSpPr>
         <p:spPr>
           <a:xfrm>
-            <a:off x="2011680" y="4114800"/>
+            <a:off x="2011680" y="4434840"/>
             <a:ext cx="5029200" cy="365760"/>
           </a:xfrm>
           <a:prstGeom prst="rect">

</xml_diff>